<commit_message>
Update ML presentation with latest analysis findings
</commit_message>
<xml_diff>
--- a/Documentation/ML_PPT.pptx
+++ b/Documentation/ML_PPT.pptx
@@ -208,7 +208,7 @@
           <a:p>
             <a:fld id="{830881A4-97E0-4626-BA30-074D23D3B5E2}" type="datetimeFigureOut">
               <a:rPr lang="en-IN" smtClean="0"/>
-              <a:t>18-05-2026</a:t>
+              <a:t>20-05-2026</a:t>
             </a:fld>
             <a:endParaRPr lang="en-IN"/>
           </a:p>
@@ -3664,14 +3664,14 @@
           <p:nvPr>
             <p:extLst>
               <p:ext uri="{D42A27DB-BD31-4B8C-83A1-F6EECF244321}">
-                <p14:modId xmlns:p14="http://schemas.microsoft.com/office/powerpoint/2010/main" val="3981006501"/>
+                <p14:modId xmlns:p14="http://schemas.microsoft.com/office/powerpoint/2010/main" val="2279242568"/>
               </p:ext>
             </p:extLst>
           </p:nvPr>
         </p:nvGraphicFramePr>
         <p:xfrm>
           <a:off x="245265" y="3429000"/>
-          <a:ext cx="11701463" cy="1818834"/>
+          <a:ext cx="11701463" cy="2184594"/>
         </p:xfrm>
         <a:graphic>
           <a:graphicData uri="http://schemas.openxmlformats.org/drawingml/2006/table">
@@ -3793,15 +3793,10 @@
                       <a:pPr algn="l"/>
                       <a:r>
                         <a:rPr lang="en-US" sz="2400" b="1" dirty="0">
-                          <a:solidFill>
-                            <a:schemeClr val="tx1"/>
-                          </a:solidFill>
-                          <a:effectLst/>
                           <a:latin typeface="Cambria" panose="02040503050406030204" pitchFamily="18" charset="0"/>
                           <a:ea typeface="Cambria" panose="02040503050406030204" pitchFamily="18" charset="0"/>
-                          <a:cs typeface="Times New Roman" pitchFamily="18" charset="0"/>
                         </a:rPr>
-                        <a:t>Market Demand Prediction Using LR and SVM</a:t>
+                        <a:t>Predictive Market Demand Analysis in E-Commerce Using Linear Regression and Support Vector Machine (SVM)</a:t>
                       </a:r>
                       <a:endParaRPr lang="en-IN" sz="2200" b="1" dirty="0">
                         <a:solidFill>

</xml_diff>